<commit_message>
feat: initialize HASS and English lesson 17 resources, including a new interactive government structure website and supplementary slides.
</commit_message>
<xml_diff>
--- a/Units/English/English_Unit_2/Lesson_Plans/Lesson_17/Lesson_17_Presentation.pptx
+++ b/Units/English/English_Unit_2/Lesson_Plans/Lesson_17/Lesson_17_Presentation.pptx
@@ -1417,8 +1417,8 @@
         </p:nvSpPr>
         <p:spPr>
           <a:xfrm>
-            <a:off x="461010" y="1889522"/>
-            <a:ext cx="11269980" cy="1009650"/>
+            <a:off x="266700" y="2157561"/>
+            <a:ext cx="11658600" cy="914400"/>
           </a:xfrm>
           <a:prstGeom prst="rect">
             <a:avLst/>
@@ -1432,15 +1432,15 @@
           <a:p>
             <a:pPr algn="ctr" indent="0" marL="0">
               <a:spcBef>
-                <a:spcPts val="4020"/>
+                <a:spcPts val="3618"/>
               </a:spcBef>
               <a:spcAft>
-                <a:spcPts val="1500"/>
+                <a:spcPts val="750"/>
               </a:spcAft>
               <a:buNone/>
             </a:pPr>
             <a:r>
-              <a:rPr lang="en-US" sz="6000" b="1" dirty="0">
+              <a:rPr lang="en-US" sz="5400" b="1" dirty="0">
                 <a:solidFill>
                   <a:srgbClr val="F96D00"/>
                 </a:solidFill>
@@ -1450,7 +1450,7 @@
               </a:rPr>
               <a:t>INFORMATION REPORTS</a:t>
             </a:r>
-            <a:endParaRPr lang="en-US" sz="6000" dirty="0"/>
+            <a:endParaRPr lang="en-US" sz="5400" dirty="0"/>
           </a:p>
         </p:txBody>
       </p:sp>
@@ -1462,8 +1462,8 @@
         </p:nvSpPr>
         <p:spPr>
           <a:xfrm>
-            <a:off x="461010" y="3469035"/>
-            <a:ext cx="11269980" cy="609600"/>
+            <a:off x="266700" y="3483322"/>
+            <a:ext cx="11658600" cy="504825"/>
           </a:xfrm>
           <a:prstGeom prst="rect">
             <a:avLst/>
@@ -1477,15 +1477,15 @@
           <a:p>
             <a:pPr algn="ctr" indent="0" marL="0">
               <a:spcBef>
-                <a:spcPts val="2988"/>
+                <a:spcPts val="2490"/>
               </a:spcBef>
               <a:spcAft>
-                <a:spcPts val="3000"/>
+                <a:spcPts val="2250"/>
               </a:spcAft>
               <a:buNone/>
             </a:pPr>
             <a:r>
-              <a:rPr lang="en-US" sz="3600" b="1" dirty="0">
+              <a:rPr lang="en-US" sz="3000" b="1" dirty="0">
                 <a:solidFill>
                   <a:srgbClr val="3F72AF"/>
                 </a:solidFill>
@@ -1495,7 +1495,7 @@
               </a:rPr>
               <a:t>Lesson 17: Planning an Information Report</a:t>
             </a:r>
-            <a:endParaRPr lang="en-US" sz="3600" dirty="0"/>
+            <a:endParaRPr lang="en-US" sz="3000" dirty="0"/>
           </a:p>
         </p:txBody>
       </p:sp>
@@ -1507,8 +1507,8 @@
         </p:nvSpPr>
         <p:spPr>
           <a:xfrm>
-            <a:off x="461010" y="4764435"/>
-            <a:ext cx="11269980" cy="409575"/>
+            <a:off x="266700" y="4540597"/>
+            <a:ext cx="11658600" cy="352425"/>
           </a:xfrm>
           <a:prstGeom prst="rect">
             <a:avLst/>
@@ -1522,15 +1522,15 @@
           <a:p>
             <a:pPr algn="ctr" indent="0" marL="0">
               <a:spcBef>
-                <a:spcPts val="2400"/>
+                <a:spcPts val="2100"/>
               </a:spcBef>
               <a:spcAft>
-                <a:spcPts val="2400"/>
+                <a:spcPts val="2100"/>
               </a:spcAft>
               <a:buNone/>
             </a:pPr>
             <a:r>
-              <a:rPr lang="en-US" sz="2400" dirty="0">
+              <a:rPr lang="en-US" sz="2100" dirty="0">
                 <a:solidFill>
                   <a:srgbClr val="E0E0E0"/>
                 </a:solidFill>
@@ -1540,7 +1540,7 @@
               </a:rPr>
               <a:t>Using the Bushfires Archive as a Structural Model</a:t>
             </a:r>
-            <a:endParaRPr lang="en-US" sz="2400" dirty="0"/>
+            <a:endParaRPr lang="en-US" sz="2100" dirty="0"/>
           </a:p>
         </p:txBody>
       </p:sp>
@@ -1584,8 +1584,8 @@
         </p:nvSpPr>
         <p:spPr>
           <a:xfrm>
-            <a:off x="571500" y="2742009"/>
-            <a:ext cx="11269980" cy="1097161"/>
+            <a:off x="571500" y="2033736"/>
+            <a:ext cx="11269980" cy="746522"/>
           </a:xfrm>
           <a:prstGeom prst="rect">
             <a:avLst/>
@@ -1599,18 +1599,18 @@
           <a:p>
             <a:pPr algn="l" indent="0" marL="0">
               <a:lnSpc>
-                <a:spcPts val="4320"/>
+                <a:spcPts val="2940"/>
               </a:lnSpc>
               <a:spcBef>
-                <a:spcPts val="2700"/>
+                <a:spcPts val="2100"/>
               </a:spcBef>
               <a:spcAft>
-                <a:spcPts val="2700"/>
+                <a:spcPts val="2100"/>
               </a:spcAft>
               <a:buNone/>
             </a:pPr>
             <a:r>
-              <a:rPr lang="en-US" sz="2700" dirty="0">
+              <a:rPr lang="en-US" sz="2100" dirty="0">
                 <a:solidFill>
                   <a:srgbClr val="333333"/>
                 </a:solidFill>
@@ -1622,18 +1622,18 @@
             </a:r>
             <a:pPr algn="l" indent="0" marL="0">
               <a:lnSpc>
-                <a:spcPts val="4320"/>
+                <a:spcPts val="2940"/>
               </a:lnSpc>
               <a:spcBef>
-                <a:spcPts val="2700"/>
+                <a:spcPts val="2100"/>
               </a:spcBef>
               <a:spcAft>
-                <a:spcPts val="2700"/>
+                <a:spcPts val="2100"/>
               </a:spcAft>
               <a:buNone/>
             </a:pPr>
             <a:r>
-              <a:rPr lang="en-US" sz="2700" b="1" dirty="0">
+              <a:rPr lang="en-US" sz="2100" b="1" dirty="0">
                 <a:solidFill>
                   <a:srgbClr val="F96D00"/>
                 </a:solidFill>
@@ -1645,18 +1645,18 @@
             </a:r>
             <a:pPr algn="l" indent="0" marL="0">
               <a:lnSpc>
-                <a:spcPts val="4320"/>
+                <a:spcPts val="2940"/>
               </a:lnSpc>
               <a:spcBef>
-                <a:spcPts val="2700"/>
+                <a:spcPts val="2100"/>
               </a:spcBef>
               <a:spcAft>
-                <a:spcPts val="2700"/>
+                <a:spcPts val="2100"/>
               </a:spcAft>
               <a:buNone/>
             </a:pPr>
             <a:r>
-              <a:rPr lang="en-US" sz="2700" dirty="0">
+              <a:rPr lang="en-US" sz="2100" dirty="0">
                 <a:solidFill>
                   <a:srgbClr val="333333"/>
                 </a:solidFill>
@@ -1666,7 +1666,7 @@
               </a:rPr>
               <a:t> using structural features modelled on the Bushfires Archive.</a:t>
             </a:r>
-            <a:endParaRPr lang="en-US" sz="2700" dirty="0"/>
+            <a:endParaRPr lang="en-US" sz="2100" dirty="0"/>
           </a:p>
         </p:txBody>
       </p:sp>
@@ -1678,8 +1678,8 @@
         </p:nvSpPr>
         <p:spPr>
           <a:xfrm>
-            <a:off x="571500" y="5111651"/>
-            <a:ext cx="11269980" cy="609600"/>
+            <a:off x="571500" y="3046958"/>
+            <a:ext cx="11269980" cy="426690"/>
           </a:xfrm>
           <a:prstGeom prst="rect">
             <a:avLst/>
@@ -1693,18 +1693,15 @@
           <a:p>
             <a:pPr algn="l" indent="0" marL="0">
               <a:lnSpc>
-                <a:spcPts val="4800"/>
+                <a:spcPts val="3360"/>
               </a:lnSpc>
               <a:spcBef>
-                <a:spcPts val="3000"/>
+                <a:spcPts val="1500"/>
               </a:spcBef>
-              <a:spcAft>
-                <a:spcPts val="3000"/>
-              </a:spcAft>
               <a:buNone/>
             </a:pPr>
             <a:r>
-              <a:rPr lang="en-US" sz="3000" b="1" dirty="0">
+              <a:rPr lang="en-US" sz="2400" b="1" dirty="0">
                 <a:solidFill>
                   <a:srgbClr val="3F72AF"/>
                 </a:solidFill>
@@ -1714,7 +1711,7 @@
               </a:rPr>
               <a:t>Success Criteria:</a:t>
             </a:r>
-            <a:endParaRPr lang="en-US" sz="3000" dirty="0"/>
+            <a:endParaRPr lang="en-US" sz="2400" dirty="0"/>
           </a:p>
         </p:txBody>
       </p:sp>
@@ -1726,8 +1723,8 @@
         </p:nvSpPr>
         <p:spPr>
           <a:xfrm>
-            <a:off x="571500" y="6102251"/>
-            <a:ext cx="11049000" cy="2026741"/>
+            <a:off x="571500" y="3568898"/>
+            <a:ext cx="11049000" cy="1310283"/>
           </a:xfrm>
           <a:prstGeom prst="rect">
             <a:avLst/>
@@ -1741,16 +1738,16 @@
           <a:p>
             <a:pPr algn="l" marL="190500" indent="-190500">
               <a:lnSpc>
-                <a:spcPts val="4320"/>
-              </a:lnSpc>
-              <a:spcAft>
-                <a:spcPts val="1500"/>
+                <a:spcPts val="2940"/>
+              </a:lnSpc>
+              <a:spcAft>
+                <a:spcPts val="750"/>
               </a:spcAft>
               <a:buSzPct val="100000"/>
               <a:buChar char="•"/>
             </a:pPr>
             <a:r>
-              <a:rPr lang="en-US" sz="2700" dirty="0">
+              <a:rPr lang="en-US" sz="2100" dirty="0">
                 <a:solidFill>
                   <a:srgbClr val="333333"/>
                 </a:solidFill>
@@ -1760,21 +1757,21 @@
               </a:rPr>
               <a:t>I can choose a natural disaster topic.</a:t>
             </a:r>
-            <a:endParaRPr lang="en-US" sz="2700" dirty="0"/>
+            <a:endParaRPr lang="en-US" sz="2100" dirty="0"/>
           </a:p>
           <a:p>
             <a:pPr algn="l" marL="190500" indent="-190500">
               <a:lnSpc>
-                <a:spcPts val="4320"/>
-              </a:lnSpc>
-              <a:spcAft>
-                <a:spcPts val="1500"/>
+                <a:spcPts val="2940"/>
+              </a:lnSpc>
+              <a:spcAft>
+                <a:spcPts val="750"/>
               </a:spcAft>
               <a:buSzPct val="100000"/>
               <a:buChar char="•"/>
             </a:pPr>
             <a:r>
-              <a:rPr lang="en-US" sz="2700" dirty="0">
+              <a:rPr lang="en-US" sz="2100" dirty="0">
                 <a:solidFill>
                   <a:srgbClr val="333333"/>
                 </a:solidFill>
@@ -1784,21 +1781,21 @@
               </a:rPr>
               <a:t>I can use a planning scaffold to organize my ideas.</a:t>
             </a:r>
-            <a:endParaRPr lang="en-US" sz="2700" dirty="0"/>
+            <a:endParaRPr lang="en-US" sz="2100" dirty="0"/>
           </a:p>
           <a:p>
             <a:pPr algn="l" marL="190500" indent="-190500">
               <a:lnSpc>
-                <a:spcPts val="4320"/>
-              </a:lnSpc>
-              <a:spcAft>
-                <a:spcPts val="1500"/>
+                <a:spcPts val="2940"/>
+              </a:lnSpc>
+              <a:spcAft>
+                <a:spcPts val="750"/>
               </a:spcAft>
               <a:buSzPct val="100000"/>
               <a:buChar char="•"/>
             </a:pPr>
             <a:r>
-              <a:rPr lang="en-US" sz="2700" dirty="0">
+              <a:rPr lang="en-US" sz="2100" dirty="0">
                 <a:solidFill>
                   <a:srgbClr val="333333"/>
                 </a:solidFill>
@@ -1808,7 +1805,7 @@
               </a:rPr>
               <a:t>I can include at least 3 researched facts in my plan.</a:t>
             </a:r>
-            <a:endParaRPr lang="en-US" sz="2700" dirty="0"/>
+            <a:endParaRPr lang="en-US" sz="2100" dirty="0"/>
           </a:p>
         </p:txBody>
       </p:sp>
@@ -1852,8 +1849,8 @@
         </p:nvSpPr>
         <p:spPr>
           <a:xfrm>
-            <a:off x="571500" y="2742009"/>
-            <a:ext cx="11269980" cy="548580"/>
+            <a:off x="571500" y="2033736"/>
+            <a:ext cx="11269980" cy="373261"/>
           </a:xfrm>
           <a:prstGeom prst="rect">
             <a:avLst/>
@@ -1867,18 +1864,18 @@
           <a:p>
             <a:pPr algn="l" indent="0" marL="0">
               <a:lnSpc>
-                <a:spcPts val="4320"/>
+                <a:spcPts val="2940"/>
               </a:lnSpc>
               <a:spcBef>
-                <a:spcPts val="2700"/>
+                <a:spcPts val="2100"/>
               </a:spcBef>
               <a:spcAft>
-                <a:spcPts val="2700"/>
+                <a:spcPts val="2100"/>
               </a:spcAft>
               <a:buNone/>
             </a:pPr>
             <a:r>
-              <a:rPr lang="en-US" sz="2700" dirty="0">
+              <a:rPr lang="en-US" sz="2100" dirty="0">
                 <a:solidFill>
                   <a:srgbClr val="333333"/>
                 </a:solidFill>
@@ -1888,7 +1885,7 @@
               </a:rPr>
               <a:t>It's time to start planning your final assessment (Part B)!</a:t>
             </a:r>
-            <a:endParaRPr lang="en-US" sz="2700" dirty="0"/>
+            <a:endParaRPr lang="en-US" sz="2100" dirty="0"/>
           </a:p>
         </p:txBody>
       </p:sp>
@@ -1900,8 +1897,8 @@
         </p:nvSpPr>
         <p:spPr>
           <a:xfrm>
-            <a:off x="571500" y="3633490"/>
-            <a:ext cx="11269980" cy="548580"/>
+            <a:off x="571500" y="2673697"/>
+            <a:ext cx="11269980" cy="373261"/>
           </a:xfrm>
           <a:prstGeom prst="rect">
             <a:avLst/>
@@ -1915,18 +1912,18 @@
           <a:p>
             <a:pPr algn="l" indent="0" marL="0">
               <a:lnSpc>
-                <a:spcPts val="4320"/>
+                <a:spcPts val="2940"/>
               </a:lnSpc>
               <a:spcBef>
-                <a:spcPts val="2700"/>
+                <a:spcPts val="2100"/>
               </a:spcBef>
               <a:spcAft>
-                <a:spcPts val="2700"/>
+                <a:spcPts val="2100"/>
               </a:spcAft>
               <a:buNone/>
             </a:pPr>
             <a:r>
-              <a:rPr lang="en-US" sz="2700" dirty="0">
+              <a:rPr lang="en-US" sz="2100" dirty="0">
                 <a:solidFill>
                   <a:srgbClr val="333333"/>
                 </a:solidFill>
@@ -1938,18 +1935,18 @@
             </a:r>
             <a:pPr algn="l" indent="0" marL="0">
               <a:lnSpc>
-                <a:spcPts val="4320"/>
+                <a:spcPts val="2940"/>
               </a:lnSpc>
               <a:spcBef>
-                <a:spcPts val="2700"/>
+                <a:spcPts val="2100"/>
               </a:spcBef>
               <a:spcAft>
-                <a:spcPts val="2700"/>
+                <a:spcPts val="2100"/>
               </a:spcAft>
               <a:buNone/>
             </a:pPr>
             <a:r>
-              <a:rPr lang="en-US" sz="2700" b="1" dirty="0">
+              <a:rPr lang="en-US" sz="2100" b="1" dirty="0">
                 <a:solidFill>
                   <a:srgbClr val="333333"/>
                 </a:solidFill>
@@ -1961,18 +1958,18 @@
             </a:r>
             <a:pPr algn="l" indent="0" marL="0">
               <a:lnSpc>
-                <a:spcPts val="4320"/>
+                <a:spcPts val="2940"/>
               </a:lnSpc>
               <a:spcBef>
-                <a:spcPts val="2700"/>
+                <a:spcPts val="2100"/>
               </a:spcBef>
               <a:spcAft>
-                <a:spcPts val="2700"/>
+                <a:spcPts val="2100"/>
               </a:spcAft>
               <a:buNone/>
             </a:pPr>
             <a:r>
-              <a:rPr lang="en-US" sz="2700" dirty="0">
+              <a:rPr lang="en-US" sz="2100" dirty="0">
                 <a:solidFill>
                   <a:srgbClr val="333333"/>
                 </a:solidFill>
@@ -1982,7 +1979,7 @@
               </a:rPr>
               <a:t> to research and report on.</a:t>
             </a:r>
-            <a:endParaRPr lang="en-US" sz="2700" dirty="0"/>
+            <a:endParaRPr lang="en-US" sz="2100" dirty="0"/>
           </a:p>
         </p:txBody>
       </p:sp>
@@ -1994,12 +1991,12 @@
         </p:nvSpPr>
         <p:spPr>
           <a:xfrm>
-            <a:off x="571500" y="4563070"/>
-            <a:ext cx="11049000" cy="2312491"/>
+            <a:off x="571500" y="3313658"/>
+            <a:ext cx="11049000" cy="1596033"/>
           </a:xfrm>
           <a:prstGeom prst="roundRect">
             <a:avLst>
-              <a:gd name="adj" fmla="val 3295"/>
+              <a:gd name="adj" fmla="val 4774"/>
             </a:avLst>
           </a:prstGeom>
           <a:solidFill>
@@ -2026,8 +2023,8 @@
         </p:nvSpPr>
         <p:spPr>
           <a:xfrm>
-            <a:off x="609600" y="4563070"/>
-            <a:ext cx="0" cy="2312491"/>
+            <a:off x="609600" y="3313658"/>
+            <a:ext cx="0" cy="1596033"/>
           </a:xfrm>
           <a:prstGeom prst="line">
             <a:avLst/>
@@ -2049,8 +2046,8 @@
         </p:nvSpPr>
         <p:spPr>
           <a:xfrm>
-            <a:off x="933450" y="4848820"/>
-            <a:ext cx="10609326" cy="548580"/>
+            <a:off x="838200" y="3504158"/>
+            <a:ext cx="10803636" cy="373261"/>
           </a:xfrm>
           <a:prstGeom prst="rect">
             <a:avLst/>
@@ -2064,12 +2061,12 @@
           <a:p>
             <a:pPr algn="l" indent="0" marL="0">
               <a:lnSpc>
-                <a:spcPts val="4320"/>
+                <a:spcPts val="2940"/>
               </a:lnSpc>
               <a:buNone/>
             </a:pPr>
             <a:r>
-              <a:rPr lang="en-US" sz="2700" b="1" dirty="0">
+              <a:rPr lang="en-US" sz="2100" b="1" dirty="0">
                 <a:solidFill>
                   <a:srgbClr val="112D4E"/>
                 </a:solidFill>
@@ -2079,7 +2076,7 @@
               </a:rPr>
               <a:t>Discussion:</a:t>
             </a:r>
-            <a:endParaRPr lang="en-US" sz="2700" dirty="0"/>
+            <a:endParaRPr lang="en-US" sz="2100" dirty="0"/>
           </a:p>
         </p:txBody>
       </p:sp>
@@ -2091,8 +2088,8 @@
         </p:nvSpPr>
         <p:spPr>
           <a:xfrm>
-            <a:off x="933450" y="5492651"/>
-            <a:ext cx="10401300" cy="1097161"/>
+            <a:off x="838200" y="3972669"/>
+            <a:ext cx="10591800" cy="746522"/>
           </a:xfrm>
           <a:prstGeom prst="rect">
             <a:avLst/>
@@ -2106,13 +2103,13 @@
           <a:p>
             <a:pPr algn="l" marL="190500" indent="-190500">
               <a:lnSpc>
-                <a:spcPts val="4320"/>
+                <a:spcPts val="2940"/>
               </a:lnSpc>
               <a:buSzPct val="100000"/>
               <a:buChar char="•"/>
             </a:pPr>
             <a:r>
-              <a:rPr lang="en-US" sz="2700" dirty="0">
+              <a:rPr lang="en-US" sz="2100" dirty="0">
                 <a:solidFill>
                   <a:srgbClr val="333333"/>
                 </a:solidFill>
@@ -2122,18 +2119,18 @@
               </a:rPr>
               <a:t>What natural disaster are you most interested in?</a:t>
             </a:r>
-            <a:endParaRPr lang="en-US" sz="2700" dirty="0"/>
+            <a:endParaRPr lang="en-US" sz="2100" dirty="0"/>
           </a:p>
           <a:p>
             <a:pPr algn="l" marL="190500" indent="-190500">
               <a:lnSpc>
-                <a:spcPts val="4320"/>
+                <a:spcPts val="2940"/>
               </a:lnSpc>
               <a:buSzPct val="100000"/>
               <a:buChar char="•"/>
             </a:pPr>
             <a:r>
-              <a:rPr lang="en-US" sz="2700" dirty="0">
+              <a:rPr lang="en-US" sz="2100" dirty="0">
                 <a:solidFill>
                   <a:srgbClr val="333333"/>
                 </a:solidFill>
@@ -2143,7 +2140,7 @@
               </a:rPr>
               <a:t>Why is planning an important step before we start writing?</a:t>
             </a:r>
-            <a:endParaRPr lang="en-US" sz="2700" dirty="0"/>
+            <a:endParaRPr lang="en-US" sz="2100" dirty="0"/>
           </a:p>
         </p:txBody>
       </p:sp>
@@ -2187,8 +2184,8 @@
         </p:nvSpPr>
         <p:spPr>
           <a:xfrm>
-            <a:off x="571500" y="2703909"/>
-            <a:ext cx="11269980" cy="426690"/>
+            <a:off x="571500" y="2033736"/>
+            <a:ext cx="11269980" cy="373261"/>
           </a:xfrm>
           <a:prstGeom prst="rect">
             <a:avLst/>
@@ -2202,18 +2199,18 @@
           <a:p>
             <a:pPr algn="l" indent="0" marL="0">
               <a:lnSpc>
-                <a:spcPts val="3360"/>
+                <a:spcPts val="2940"/>
               </a:lnSpc>
               <a:spcBef>
-                <a:spcPts val="2400"/>
+                <a:spcPts val="2100"/>
               </a:spcBef>
               <a:spcAft>
-                <a:spcPts val="2400"/>
+                <a:spcPts val="2100"/>
               </a:spcAft>
               <a:buNone/>
             </a:pPr>
             <a:r>
-              <a:rPr lang="en-US" sz="2400" dirty="0">
+              <a:rPr lang="en-US" sz="2100" dirty="0">
                 <a:solidFill>
                   <a:srgbClr val="333333"/>
                 </a:solidFill>
@@ -2223,7 +2220,7 @@
               </a:rPr>
               <a:t>The Bushfires Archive hub page serves as a model for our own reports.</a:t>
             </a:r>
-            <a:endParaRPr lang="en-US" sz="2400" dirty="0"/>
+            <a:endParaRPr lang="en-US" sz="2100" dirty="0"/>
           </a:p>
         </p:txBody>
       </p:sp>
@@ -2267,8 +2264,8 @@
         </p:nvSpPr>
         <p:spPr>
           <a:xfrm>
-            <a:off x="571500" y="2742009"/>
-            <a:ext cx="11269980" cy="548580"/>
+            <a:off x="571500" y="2033736"/>
+            <a:ext cx="11269980" cy="373261"/>
           </a:xfrm>
           <a:prstGeom prst="rect">
             <a:avLst/>
@@ -2282,18 +2279,18 @@
           <a:p>
             <a:pPr algn="l" indent="0" marL="0">
               <a:lnSpc>
-                <a:spcPts val="4320"/>
+                <a:spcPts val="2940"/>
               </a:lnSpc>
               <a:spcBef>
-                <a:spcPts val="2700"/>
+                <a:spcPts val="2100"/>
               </a:spcBef>
               <a:spcAft>
-                <a:spcPts val="2700"/>
+                <a:spcPts val="2100"/>
               </a:spcAft>
               <a:buNone/>
             </a:pPr>
             <a:r>
-              <a:rPr lang="en-US" sz="2700" dirty="0">
+              <a:rPr lang="en-US" sz="2100" dirty="0">
                 <a:solidFill>
                   <a:srgbClr val="333333"/>
                 </a:solidFill>
@@ -2305,18 +2302,18 @@
             </a:r>
             <a:pPr algn="l" indent="0" marL="0">
               <a:lnSpc>
-                <a:spcPts val="4320"/>
+                <a:spcPts val="2940"/>
               </a:lnSpc>
               <a:spcBef>
-                <a:spcPts val="2700"/>
+                <a:spcPts val="2100"/>
               </a:spcBef>
               <a:spcAft>
-                <a:spcPts val="2700"/>
+                <a:spcPts val="2100"/>
               </a:spcAft>
               <a:buNone/>
             </a:pPr>
             <a:r>
-              <a:rPr lang="en-US" sz="2700" b="1" dirty="0">
+              <a:rPr lang="en-US" sz="2100" b="1" dirty="0">
                 <a:solidFill>
                   <a:srgbClr val="112D4E"/>
                 </a:solidFill>
@@ -2328,18 +2325,18 @@
             </a:r>
             <a:pPr algn="l" indent="0" marL="0">
               <a:lnSpc>
-                <a:spcPts val="4320"/>
+                <a:spcPts val="2940"/>
               </a:lnSpc>
               <a:spcBef>
-                <a:spcPts val="2700"/>
+                <a:spcPts val="2100"/>
               </a:spcBef>
               <a:spcAft>
-                <a:spcPts val="2700"/>
+                <a:spcPts val="2100"/>
               </a:spcAft>
               <a:buNone/>
             </a:pPr>
             <a:r>
-              <a:rPr lang="en-US" sz="2700" dirty="0">
+              <a:rPr lang="en-US" sz="2100" dirty="0">
                 <a:solidFill>
                   <a:srgbClr val="333333"/>
                 </a:solidFill>
@@ -2349,7 +2346,7 @@
               </a:rPr>
               <a:t>.</a:t>
             </a:r>
-            <a:endParaRPr lang="en-US" sz="2700" dirty="0"/>
+            <a:endParaRPr lang="en-US" sz="2100" dirty="0"/>
           </a:p>
         </p:txBody>
       </p:sp>
@@ -2361,8 +2358,8 @@
         </p:nvSpPr>
         <p:spPr>
           <a:xfrm>
-            <a:off x="571500" y="3633490"/>
-            <a:ext cx="11049000" cy="4137422"/>
+            <a:off x="571500" y="2673697"/>
+            <a:ext cx="11049000" cy="2300883"/>
           </a:xfrm>
           <a:prstGeom prst="rect">
             <a:avLst/>
@@ -2391,8 +2388,8 @@
         </p:nvSpPr>
         <p:spPr>
           <a:xfrm>
-            <a:off x="609600" y="3633490"/>
-            <a:ext cx="0" cy="4137422"/>
+            <a:off x="609600" y="2673697"/>
+            <a:ext cx="0" cy="2300883"/>
           </a:xfrm>
           <a:prstGeom prst="line">
             <a:avLst/>
@@ -2414,8 +2411,8 @@
         </p:nvSpPr>
         <p:spPr>
           <a:xfrm>
-            <a:off x="933450" y="4262140"/>
-            <a:ext cx="10609326" cy="548580"/>
+            <a:off x="838200" y="3130897"/>
+            <a:ext cx="10803636" cy="373261"/>
           </a:xfrm>
           <a:prstGeom prst="rect">
             <a:avLst/>
@@ -2429,18 +2426,18 @@
           <a:p>
             <a:pPr algn="l" indent="0" marL="0">
               <a:lnSpc>
-                <a:spcPts val="4320"/>
+                <a:spcPts val="2940"/>
               </a:lnSpc>
               <a:spcBef>
-                <a:spcPts val="2700"/>
+                <a:spcPts val="2100"/>
               </a:spcBef>
               <a:spcAft>
-                <a:spcPts val="2700"/>
+                <a:spcPts val="2100"/>
               </a:spcAft>
               <a:buNone/>
             </a:pPr>
             <a:r>
-              <a:rPr lang="en-US" sz="2700" dirty="0">
+              <a:rPr lang="en-US" sz="2100" dirty="0">
                 <a:solidFill>
                   <a:srgbClr val="333333"/>
                 </a:solidFill>
@@ -2452,18 +2449,18 @@
             </a:r>
             <a:pPr algn="l" indent="0" marL="0">
               <a:lnSpc>
-                <a:spcPts val="4320"/>
+                <a:spcPts val="2940"/>
               </a:lnSpc>
               <a:spcBef>
-                <a:spcPts val="2700"/>
+                <a:spcPts val="2100"/>
               </a:spcBef>
               <a:spcAft>
-                <a:spcPts val="2700"/>
+                <a:spcPts val="2100"/>
               </a:spcAft>
               <a:buNone/>
             </a:pPr>
             <a:r>
-              <a:rPr lang="en-US" sz="2700" b="1" i="1" dirty="0">
+              <a:rPr lang="en-US" sz="2100" b="1" i="1" dirty="0">
                 <a:solidFill>
                   <a:srgbClr val="3F72AF"/>
                 </a:solidFill>
@@ -2475,18 +2472,18 @@
             </a:r>
             <a:pPr algn="l" indent="0" marL="0">
               <a:lnSpc>
-                <a:spcPts val="4320"/>
+                <a:spcPts val="2940"/>
               </a:lnSpc>
               <a:spcBef>
-                <a:spcPts val="2700"/>
+                <a:spcPts val="2100"/>
               </a:spcBef>
               <a:spcAft>
-                <a:spcPts val="2700"/>
+                <a:spcPts val="2100"/>
               </a:spcAft>
               <a:buNone/>
             </a:pPr>
             <a:r>
-              <a:rPr lang="en-US" sz="2700" dirty="0">
+              <a:rPr lang="en-US" sz="2100" dirty="0">
                 <a:solidFill>
                   <a:srgbClr val="333333"/>
                 </a:solidFill>
@@ -2496,7 +2493,7 @@
               </a:rPr>
               <a:t> to introduce what a tsunami is."</a:t>
             </a:r>
-            <a:endParaRPr lang="en-US" sz="2700" dirty="0"/>
+            <a:endParaRPr lang="en-US" sz="2100" dirty="0"/>
           </a:p>
         </p:txBody>
       </p:sp>
@@ -2508,8 +2505,8 @@
         </p:nvSpPr>
         <p:spPr>
           <a:xfrm>
-            <a:off x="933450" y="6045101"/>
-            <a:ext cx="10609326" cy="1097161"/>
+            <a:off x="838200" y="3770858"/>
+            <a:ext cx="10803636" cy="746522"/>
           </a:xfrm>
           <a:prstGeom prst="rect">
             <a:avLst/>
@@ -2523,18 +2520,18 @@
           <a:p>
             <a:pPr algn="l" indent="0" marL="0">
               <a:lnSpc>
-                <a:spcPts val="4320"/>
+                <a:spcPts val="2940"/>
               </a:lnSpc>
               <a:spcBef>
-                <a:spcPts val="2700"/>
+                <a:spcPts val="1125"/>
               </a:spcBef>
               <a:spcAft>
-                <a:spcPts val="2700"/>
+                <a:spcPts val="2100"/>
               </a:spcAft>
               <a:buNone/>
             </a:pPr>
             <a:r>
-              <a:rPr lang="en-US" sz="2700" dirty="0">
+              <a:rPr lang="en-US" sz="2100" dirty="0">
                 <a:solidFill>
                   <a:srgbClr val="333333"/>
                 </a:solidFill>
@@ -2546,18 +2543,18 @@
             </a:r>
             <a:pPr algn="l" indent="0" marL="0">
               <a:lnSpc>
-                <a:spcPts val="4320"/>
+                <a:spcPts val="2940"/>
               </a:lnSpc>
               <a:spcBef>
-                <a:spcPts val="2700"/>
+                <a:spcPts val="1125"/>
               </a:spcBef>
               <a:spcAft>
-                <a:spcPts val="2700"/>
+                <a:spcPts val="2100"/>
               </a:spcAft>
               <a:buNone/>
             </a:pPr>
             <a:r>
-              <a:rPr lang="en-US" sz="2700" b="1" i="1" dirty="0">
+              <a:rPr lang="en-US" sz="2100" b="1" i="1" dirty="0">
                 <a:solidFill>
                   <a:srgbClr val="3F72AF"/>
                 </a:solidFill>
@@ -2569,18 +2566,18 @@
             </a:r>
             <a:pPr algn="l" indent="0" marL="0">
               <a:lnSpc>
-                <a:spcPts val="4320"/>
+                <a:spcPts val="2940"/>
               </a:lnSpc>
               <a:spcBef>
-                <a:spcPts val="2700"/>
+                <a:spcPts val="1125"/>
               </a:spcBef>
               <a:spcAft>
-                <a:spcPts val="2700"/>
+                <a:spcPts val="2100"/>
               </a:spcAft>
               <a:buNone/>
             </a:pPr>
             <a:r>
-              <a:rPr lang="en-US" sz="2700" dirty="0">
+              <a:rPr lang="en-US" sz="2100" dirty="0">
                 <a:solidFill>
                   <a:srgbClr val="333333"/>
                 </a:solidFill>
@@ -2590,7 +2587,7 @@
               </a:rPr>
               <a:t> behind it... like underwater earthquakes."</a:t>
             </a:r>
-            <a:endParaRPr lang="en-US" sz="2700" dirty="0"/>
+            <a:endParaRPr lang="en-US" sz="2100" dirty="0"/>
           </a:p>
         </p:txBody>
       </p:sp>
@@ -2634,8 +2631,8 @@
         </p:nvSpPr>
         <p:spPr>
           <a:xfrm>
-            <a:off x="571500" y="2742009"/>
-            <a:ext cx="11269980" cy="548580"/>
+            <a:off x="571500" y="2033736"/>
+            <a:ext cx="11269980" cy="373261"/>
           </a:xfrm>
           <a:prstGeom prst="rect">
             <a:avLst/>
@@ -2649,18 +2646,18 @@
           <a:p>
             <a:pPr algn="l" indent="0" marL="0">
               <a:lnSpc>
-                <a:spcPts val="4320"/>
+                <a:spcPts val="2940"/>
               </a:lnSpc>
               <a:spcBef>
-                <a:spcPts val="2700"/>
+                <a:spcPts val="2100"/>
               </a:spcBef>
               <a:spcAft>
-                <a:spcPts val="2700"/>
+                <a:spcPts val="2100"/>
               </a:spcAft>
               <a:buNone/>
             </a:pPr>
             <a:r>
-              <a:rPr lang="en-US" sz="2700" dirty="0">
+              <a:rPr lang="en-US" sz="2100" dirty="0">
                 <a:solidFill>
                   <a:srgbClr val="333333"/>
                 </a:solidFill>
@@ -2670,7 +2667,7 @@
               </a:rPr>
               <a:t>Now it's time to begin completing your own planning scaffold.</a:t>
             </a:r>
-            <a:endParaRPr lang="en-US" sz="2700" dirty="0"/>
+            <a:endParaRPr lang="en-US" sz="2100" dirty="0"/>
           </a:p>
         </p:txBody>
       </p:sp>
@@ -2682,8 +2679,8 @@
         </p:nvSpPr>
         <p:spPr>
           <a:xfrm>
-            <a:off x="571500" y="3633490"/>
-            <a:ext cx="11049000" cy="2575322"/>
+            <a:off x="571500" y="2673697"/>
+            <a:ext cx="11049000" cy="1310283"/>
           </a:xfrm>
           <a:prstGeom prst="rect">
             <a:avLst/>
@@ -2697,16 +2694,16 @@
           <a:p>
             <a:pPr algn="l" marL="190500" indent="-190500">
               <a:lnSpc>
-                <a:spcPts val="4320"/>
-              </a:lnSpc>
-              <a:spcAft>
-                <a:spcPts val="1500"/>
+                <a:spcPts val="2940"/>
+              </a:lnSpc>
+              <a:spcAft>
+                <a:spcPts val="750"/>
               </a:spcAft>
               <a:buSzPct val="100000"/>
               <a:buChar char="•"/>
             </a:pPr>
             <a:r>
-              <a:rPr lang="en-US" sz="2700" dirty="0">
+              <a:rPr lang="en-US" sz="2100" dirty="0">
                 <a:solidFill>
                   <a:srgbClr val="333333"/>
                 </a:solidFill>
@@ -2718,15 +2715,15 @@
             </a:r>
             <a:pPr algn="l" indent="0" marL="0">
               <a:lnSpc>
-                <a:spcPts val="4320"/>
-              </a:lnSpc>
-              <a:spcAft>
-                <a:spcPts val="1500"/>
+                <a:spcPts val="2940"/>
+              </a:lnSpc>
+              <a:spcAft>
+                <a:spcPts val="750"/>
               </a:spcAft>
               <a:buNone/>
             </a:pPr>
             <a:r>
-              <a:rPr lang="en-US" sz="2700" b="1" dirty="0">
+              <a:rPr lang="en-US" sz="2100" b="1" dirty="0">
                 <a:solidFill>
                   <a:srgbClr val="333333"/>
                 </a:solidFill>
@@ -2738,15 +2735,15 @@
             </a:r>
             <a:pPr algn="l" indent="0" marL="0">
               <a:lnSpc>
-                <a:spcPts val="4320"/>
-              </a:lnSpc>
-              <a:spcAft>
-                <a:spcPts val="1500"/>
+                <a:spcPts val="2940"/>
+              </a:lnSpc>
+              <a:spcAft>
+                <a:spcPts val="750"/>
               </a:spcAft>
               <a:buNone/>
             </a:pPr>
             <a:r>
-              <a:rPr lang="en-US" sz="2700" dirty="0">
+              <a:rPr lang="en-US" sz="2100" dirty="0">
                 <a:solidFill>
                   <a:srgbClr val="333333"/>
                 </a:solidFill>
@@ -2756,21 +2753,21 @@
               </a:rPr>
               <a:t>.</a:t>
             </a:r>
-            <a:endParaRPr lang="en-US" sz="2700" dirty="0"/>
+            <a:endParaRPr lang="en-US" sz="2100" dirty="0"/>
           </a:p>
           <a:p>
             <a:pPr algn="l" marL="190500" indent="-190500">
               <a:lnSpc>
-                <a:spcPts val="4320"/>
-              </a:lnSpc>
-              <a:spcAft>
-                <a:spcPts val="1500"/>
+                <a:spcPts val="2940"/>
+              </a:lnSpc>
+              <a:spcAft>
+                <a:spcPts val="750"/>
               </a:spcAft>
               <a:buSzPct val="100000"/>
               <a:buChar char="•"/>
             </a:pPr>
             <a:r>
-              <a:rPr lang="en-US" sz="2700" dirty="0">
+              <a:rPr lang="en-US" sz="2100" dirty="0">
                 <a:solidFill>
                   <a:srgbClr val="333333"/>
                 </a:solidFill>
@@ -2780,21 +2777,21 @@
               </a:rPr>
               <a:t>Fill in notes for each of the 5 structural stages.</a:t>
             </a:r>
-            <a:endParaRPr lang="en-US" sz="2700" dirty="0"/>
+            <a:endParaRPr lang="en-US" sz="2100" dirty="0"/>
           </a:p>
           <a:p>
             <a:pPr algn="l" marL="190500" indent="-190500">
               <a:lnSpc>
-                <a:spcPts val="4320"/>
-              </a:lnSpc>
-              <a:spcAft>
-                <a:spcPts val="1500"/>
+                <a:spcPts val="2940"/>
+              </a:lnSpc>
+              <a:spcAft>
+                <a:spcPts val="750"/>
               </a:spcAft>
               <a:buSzPct val="100000"/>
               <a:buChar char="•"/>
             </a:pPr>
             <a:r>
-              <a:rPr lang="en-US" sz="2700" dirty="0">
+              <a:rPr lang="en-US" sz="2100" dirty="0">
                 <a:solidFill>
                   <a:srgbClr val="333333"/>
                 </a:solidFill>
@@ -2806,15 +2803,15 @@
             </a:r>
             <a:pPr algn="l" indent="0" marL="0">
               <a:lnSpc>
-                <a:spcPts val="4320"/>
-              </a:lnSpc>
-              <a:spcAft>
-                <a:spcPts val="1500"/>
+                <a:spcPts val="2940"/>
+              </a:lnSpc>
+              <a:spcAft>
+                <a:spcPts val="750"/>
               </a:spcAft>
               <a:buNone/>
             </a:pPr>
             <a:r>
-              <a:rPr lang="en-US" sz="2700" b="1" dirty="0">
+              <a:rPr lang="en-US" sz="2100" b="1" dirty="0">
                 <a:solidFill>
                   <a:srgbClr val="333333"/>
                 </a:solidFill>
@@ -2826,15 +2823,15 @@
             </a:r>
             <a:pPr algn="l" indent="0" marL="0">
               <a:lnSpc>
-                <a:spcPts val="4320"/>
-              </a:lnSpc>
-              <a:spcAft>
-                <a:spcPts val="1500"/>
+                <a:spcPts val="2940"/>
+              </a:lnSpc>
+              <a:spcAft>
+                <a:spcPts val="750"/>
               </a:spcAft>
               <a:buNone/>
             </a:pPr>
             <a:r>
-              <a:rPr lang="en-US" sz="2700" dirty="0">
+              <a:rPr lang="en-US" sz="2100" dirty="0">
                 <a:solidFill>
                   <a:srgbClr val="333333"/>
                 </a:solidFill>
@@ -2844,7 +2841,7 @@
               </a:rPr>
               <a:t> sourced from the archives or your own research.</a:t>
             </a:r>
-            <a:endParaRPr lang="en-US" sz="2700" dirty="0"/>
+            <a:endParaRPr lang="en-US" sz="2100" dirty="0"/>
           </a:p>
         </p:txBody>
       </p:sp>
@@ -2888,8 +2885,8 @@
         </p:nvSpPr>
         <p:spPr>
           <a:xfrm>
-            <a:off x="266700" y="1629370"/>
-            <a:ext cx="11658600" cy="809625"/>
+            <a:off x="266700" y="1917204"/>
+            <a:ext cx="11658600" cy="704850"/>
           </a:xfrm>
           <a:prstGeom prst="rect">
             <a:avLst/>
@@ -2903,15 +2900,15 @@
           <a:p>
             <a:pPr algn="ctr" indent="0" marL="0">
               <a:spcBef>
-                <a:spcPts val="3216"/>
+                <a:spcPts val="2814"/>
               </a:spcBef>
               <a:spcAft>
-                <a:spcPts val="1500"/>
+                <a:spcPts val="750"/>
               </a:spcAft>
               <a:buNone/>
             </a:pPr>
             <a:r>
-              <a:rPr lang="en-US" sz="4800" b="1" dirty="0">
+              <a:rPr lang="en-US" sz="4200" b="1" dirty="0">
                 <a:solidFill>
                   <a:srgbClr val="F96D00"/>
                 </a:solidFill>
@@ -2921,7 +2918,7 @@
               </a:rPr>
               <a:t>Review &amp; Next Steps</a:t>
             </a:r>
-            <a:endParaRPr lang="en-US" sz="4800" dirty="0"/>
+            <a:endParaRPr lang="en-US" sz="4200" dirty="0"/>
           </a:p>
         </p:txBody>
       </p:sp>
@@ -2933,8 +2930,8 @@
         </p:nvSpPr>
         <p:spPr>
           <a:xfrm>
-            <a:off x="266700" y="2772370"/>
-            <a:ext cx="11658600" cy="479971"/>
+            <a:off x="266700" y="2860179"/>
+            <a:ext cx="11658600" cy="373261"/>
           </a:xfrm>
           <a:prstGeom prst="rect">
             <a:avLst/>
@@ -2948,7 +2945,7 @@
           <a:p>
             <a:pPr algn="ctr" indent="0" marL="0">
               <a:lnSpc>
-                <a:spcPts val="3780"/>
+                <a:spcPts val="2940"/>
               </a:lnSpc>
               <a:spcBef>
                 <a:spcPts val="1125"/>
@@ -2959,7 +2956,7 @@
               <a:buNone/>
             </a:pPr>
             <a:r>
-              <a:rPr lang="en-US" sz="2700" dirty="0">
+              <a:rPr lang="en-US" sz="2100" dirty="0">
                 <a:solidFill>
                   <a:srgbClr val="E0E0E0"/>
                 </a:solidFill>
@@ -2969,7 +2966,7 @@
               </a:rPr>
               <a:t>Today we planned the structure of our reports.</a:t>
             </a:r>
-            <a:endParaRPr lang="en-US" sz="2700" dirty="0"/>
+            <a:endParaRPr lang="en-US" sz="2100" dirty="0"/>
           </a:p>
         </p:txBody>
       </p:sp>
@@ -2981,8 +2978,8 @@
         </p:nvSpPr>
         <p:spPr>
           <a:xfrm>
-            <a:off x="266700" y="3395216"/>
-            <a:ext cx="11658600" cy="959941"/>
+            <a:off x="266700" y="3376315"/>
+            <a:ext cx="11658600" cy="746522"/>
           </a:xfrm>
           <a:prstGeom prst="rect">
             <a:avLst/>
@@ -2996,7 +2993,7 @@
           <a:p>
             <a:pPr algn="ctr" indent="0" marL="0">
               <a:lnSpc>
-                <a:spcPts val="3780"/>
+                <a:spcPts val="2940"/>
               </a:lnSpc>
               <a:spcBef>
                 <a:spcPts val="1125"/>
@@ -3007,7 +3004,7 @@
               <a:buNone/>
             </a:pPr>
             <a:r>
-              <a:rPr lang="en-US" sz="2700" dirty="0">
+              <a:rPr lang="en-US" sz="2100" dirty="0">
                 <a:solidFill>
                   <a:srgbClr val="E0E0E0"/>
                 </a:solidFill>
@@ -3020,7 +3017,7 @@
             </a:r>
             <a:pPr algn="ctr" indent="0" marL="0">
               <a:lnSpc>
-                <a:spcPts val="3780"/>
+                <a:spcPts val="2940"/>
               </a:lnSpc>
               <a:spcBef>
                 <a:spcPts val="1125"/>
@@ -3031,7 +3028,7 @@
               <a:buNone/>
             </a:pPr>
             <a:r>
-              <a:rPr lang="en-US" sz="2700" b="1" dirty="0">
+              <a:rPr lang="en-US" sz="2100" b="1" dirty="0">
                 <a:solidFill>
                   <a:srgbClr val="3F72AF"/>
                 </a:solidFill>
@@ -3043,7 +3040,7 @@
             </a:r>
             <a:pPr algn="ctr" indent="0" marL="0">
               <a:lnSpc>
-                <a:spcPts val="3780"/>
+                <a:spcPts val="2940"/>
               </a:lnSpc>
               <a:spcBef>
                 <a:spcPts val="1125"/>
@@ -3054,7 +3051,7 @@
               <a:buNone/>
             </a:pPr>
             <a:r>
-              <a:rPr lang="en-US" sz="2700" dirty="0">
+              <a:rPr lang="en-US" sz="2100" dirty="0">
                 <a:solidFill>
                   <a:srgbClr val="E0E0E0"/>
                 </a:solidFill>
@@ -3064,7 +3061,7 @@
               </a:rPr>
               <a:t>!</a:t>
             </a:r>
-            <a:endParaRPr lang="en-US" sz="2700" dirty="0"/>
+            <a:endParaRPr lang="en-US" sz="2100" dirty="0"/>
           </a:p>
         </p:txBody>
       </p:sp>
@@ -3076,7 +3073,7 @@
         </p:nvSpPr>
         <p:spPr>
           <a:xfrm>
-            <a:off x="266700" y="5120878"/>
+            <a:off x="266700" y="4781848"/>
             <a:ext cx="11658600" cy="373261"/>
           </a:xfrm>
           <a:prstGeom prst="rect">

</xml_diff>